<commit_message>
Entretiens placements et provisions du 19/10/2026 : comptes rendus, notes internes, PBC, guides, rapport v6
- Comptes rendus placements (14h) et provisions (16h) avec M. Koffi, chef comptable, logigrammes de la décision
  de placement et des allocations décès ; compte rendu cotisations complété (M. Kouamé Attuoman, participants)
- Notes internes confidentielles, une par entretien
- PBC complémentaire placements et provisions (items 80 à 99), reportée dans la PBC générale
- Guides : réponses et relances (placements, provisionnements), nom de l'interlocuteur cotisations
- Rapport v6 et classeur v6 : placements, méthode décès du FPPN, GNA apporteur d'affaires, compte 10620000,
  charges patronales de la provision retraite ; retouches de l'utilisateur sur la v5 reprises

Co-Authored-By: Claude Opus 5.5 <noreply@anthropic.com>
Claude-Session: https://claude.ai/code/session_01QrZoDwZJKb9thfUp96Ro9x
</commit_message>
<xml_diff>
--- a/entretiens/FPPN_CR_entretien_cotisations_20261019.pptx
+++ b/entretiens/FPPN_CR_entretien_cotisations_20261019.pptx
@@ -919,7 +919,7 @@
           <a:lstStyle/>
           <a:p>
             <a:r>
-              <a:t>Les participants côté FPPN sont indiqués par leur fonction ; le nom de l'interlocuteur est à compléter.</a:t>
+              <a:t>Interlocuteur : Kouamé Attuoman, responsable des cotisations et responsable informatique du FPPN.</a:t>
             </a:r>
           </a:p>
         </p:txBody>
@@ -10695,22 +10695,13 @@
               </a:spcAft>
             </a:pPr>
             <a:r>
-              <a:rPr sz="1100" b="1">
-                <a:solidFill>
-                  <a:srgbClr val="060606"/>
-                </a:solidFill>
-                <a:latin typeface="Helvetica"/>
-              </a:rPr>
-              <a:t>Implication pour la mission.</a:t>
-            </a:r>
-            <a:r>
               <a:rPr sz="1100" b="0">
                 <a:solidFill>
                   <a:srgbClr val="060606"/>
                 </a:solidFill>
                 <a:latin typeface="Helvetica"/>
               </a:rPr>
-              <a:t> Les fichiers aller maladie et décès sont à demander à la direction du personnel de la Police ou à la Solde. Les autres fichiers manquants sont à demander au responsable des cotisations, qui les dépose sur la plateforme.</a:t>
+              <a:t>Les fichiers aller maladie et décès sont à demander à la direction du personnel de la Police ou à la Solde. Les autres fichiers manquants sont à demander au responsable des cotisations, qui les dépose sur la plateforme.</a:t>
             </a:r>
           </a:p>
         </p:txBody>
@@ -10751,7 +10742,7 @@
     </p:spTree>
     <p:extLst>
       <p:ext uri="{BB962C8B-B14F-4D97-AF65-F5344CB8AC3E}">
-        <p14:creationId xmlns:p14="http://schemas.microsoft.com/office/powerpoint/2010/main" val="653024633"/>
+        <p14:creationId xmlns:p14="http://schemas.microsoft.com/office/powerpoint/2010/main" val="875498659"/>
       </p:ext>
     </p:extLst>
   </p:cSld>
@@ -11947,7 +11938,7 @@
     </p:spTree>
     <p:extLst>
       <p:ext uri="{BB962C8B-B14F-4D97-AF65-F5344CB8AC3E}">
-        <p14:creationId xmlns:p14="http://schemas.microsoft.com/office/powerpoint/2010/main" val="3000438499"/>
+        <p14:creationId xmlns:p14="http://schemas.microsoft.com/office/powerpoint/2010/main" val="317222211"/>
       </p:ext>
     </p:extLst>
   </p:cSld>
@@ -12697,7 +12688,7 @@
                 </a:solidFill>
                 <a:latin typeface="Helvetica"/>
               </a:rPr>
-              <a:t>Interlocuteur</a:t>
+              <a:t>Kouamé Attuoman</a:t>
             </a:r>
           </a:p>
         </p:txBody>
@@ -12855,7 +12846,7 @@
         </p:nvGraphicFramePr>
         <p:xfrm>
           <a:off x="503999" y="2232000"/>
-          <a:ext cx="11231999" cy="1236302"/>
+          <a:ext cx="11231999" cy="1461552"/>
         </p:xfrm>
         <a:graphic>
           <a:graphicData uri="http://schemas.openxmlformats.org/drawingml/2006/table">
@@ -13012,7 +13003,7 @@
                           </a:solidFill>
                           <a:latin typeface="Helvetica"/>
                         </a:rPr>
-                        <a:t>Nom à compléter</a:t>
+                        <a:t>Kouamé Attuoman</a:t>
                       </a:r>
                     </a:p>
                   </a:txBody>
@@ -13073,7 +13064,7 @@
                   </a:tcPr>
                 </a:tc>
               </a:tr>
-              <a:tr h="392901">
+              <a:tr h="225250">
                 <a:tc>
                   <a:txBody>
                     <a:bodyPr/>
@@ -13089,7 +13080,7 @@
                           </a:solidFill>
                           <a:latin typeface="Helvetica"/>
                         </a:rPr>
-                        <a:t>FPPN</a:t>
+                        <a:t>Adenka</a:t>
                       </a:r>
                     </a:p>
                   </a:txBody>
@@ -13114,7 +13105,7 @@
                           </a:solidFill>
                           <a:latin typeface="Helvetica"/>
                         </a:rPr>
-                        <a:t>Eliam Affolaby</a:t>
+                        <a:t>Jean-Noël Sialou</a:t>
                       </a:r>
                     </a:p>
                   </a:txBody>
@@ -13139,7 +13130,7 @@
                           </a:solidFill>
                           <a:latin typeface="Helvetica"/>
                         </a:rPr>
-                        <a:t>Fonction à préciser</a:t>
+                        <a:t>Consultant actuaire</a:t>
                       </a:r>
                     </a:p>
                   </a:txBody>
@@ -13164,7 +13155,7 @@
                           </a:solidFill>
                           <a:latin typeface="Helvetica"/>
                         </a:rPr>
-                        <a:t>Contactée par téléphone pendant l'entretien, sur la hausse de l'EFC</a:t>
+                        <a:t>Conduite de l'entretien</a:t>
                       </a:r>
                     </a:p>
                   </a:txBody>
@@ -13216,7 +13207,7 @@
                           </a:solidFill>
                           <a:latin typeface="Helvetica"/>
                         </a:rPr>
-                        <a:t>Jean-Noël Sialou</a:t>
+                        <a:t>Ruth Miensa</a:t>
                       </a:r>
                     </a:p>
                   </a:txBody>
@@ -13241,7 +13232,7 @@
                           </a:solidFill>
                           <a:latin typeface="Helvetica"/>
                         </a:rPr>
-                        <a:t>Consultant actuaire</a:t>
+                        <a:t>Équipe Adenka</a:t>
                       </a:r>
                     </a:p>
                   </a:txBody>
@@ -13266,7 +13257,7 @@
                           </a:solidFill>
                           <a:latin typeface="Helvetica"/>
                         </a:rPr>
-                        <a:t>Conduite de l'entretien</a:t>
+                        <a:t>Participante</a:t>
                       </a:r>
                     </a:p>
                   </a:txBody>
@@ -13277,6 +13268,108 @@
                   </a:tcPr>
                 </a:tc>
               </a:tr>
+              <a:tr h="392901">
+                <a:tc>
+                  <a:txBody>
+                    <a:bodyPr/>
+                    <a:lstStyle/>
+                    <a:p>
+                      <a:pPr marL="0" indent="0" lvl="0">
+                        <a:buNone/>
+                      </a:pPr>
+                      <a:r>
+                        <a:rPr sz="1100" b="1">
+                          <a:solidFill>
+                            <a:srgbClr val="060606"/>
+                          </a:solidFill>
+                          <a:latin typeface="Helvetica"/>
+                        </a:rPr>
+                        <a:t>Adenka</a:t>
+                      </a:r>
+                    </a:p>
+                  </a:txBody>
+                  <a:tcPr marL="43200" marR="43200" marT="14400" marB="14400" anchor="ctr">
+                    <a:solidFill>
+                      <a:srgbClr val="F2F2F2"/>
+                    </a:solidFill>
+                  </a:tcPr>
+                </a:tc>
+                <a:tc>
+                  <a:txBody>
+                    <a:bodyPr/>
+                    <a:lstStyle/>
+                    <a:p>
+                      <a:pPr marL="0" indent="0" lvl="0">
+                        <a:buNone/>
+                      </a:pPr>
+                      <a:r>
+                        <a:rPr sz="1100" b="0">
+                          <a:solidFill>
+                            <a:srgbClr val="060606"/>
+                          </a:solidFill>
+                          <a:latin typeface="Helvetica"/>
+                        </a:rPr>
+                        <a:t>Eliam Affolaby</a:t>
+                      </a:r>
+                    </a:p>
+                  </a:txBody>
+                  <a:tcPr marL="43200" marR="43200" marT="14400" marB="14400" anchor="ctr">
+                    <a:solidFill>
+                      <a:srgbClr val="F2F2F2"/>
+                    </a:solidFill>
+                  </a:tcPr>
+                </a:tc>
+                <a:tc>
+                  <a:txBody>
+                    <a:bodyPr/>
+                    <a:lstStyle/>
+                    <a:p>
+                      <a:pPr marL="0" indent="0" lvl="0">
+                        <a:buNone/>
+                      </a:pPr>
+                      <a:r>
+                        <a:rPr sz="1100" b="0">
+                          <a:solidFill>
+                            <a:srgbClr val="060606"/>
+                          </a:solidFill>
+                          <a:latin typeface="Helvetica"/>
+                        </a:rPr>
+                        <a:t>Équipe Adenka</a:t>
+                      </a:r>
+                    </a:p>
+                  </a:txBody>
+                  <a:tcPr marL="43200" marR="43200" marT="14400" marB="14400" anchor="ctr">
+                    <a:solidFill>
+                      <a:srgbClr val="F2F2F2"/>
+                    </a:solidFill>
+                  </a:tcPr>
+                </a:tc>
+                <a:tc>
+                  <a:txBody>
+                    <a:bodyPr/>
+                    <a:lstStyle/>
+                    <a:p>
+                      <a:pPr marL="0" indent="0" lvl="0">
+                        <a:buNone/>
+                      </a:pPr>
+                      <a:r>
+                        <a:rPr sz="1100" b="0">
+                          <a:solidFill>
+                            <a:srgbClr val="060606"/>
+                          </a:solidFill>
+                          <a:latin typeface="Helvetica"/>
+                        </a:rPr>
+                        <a:t>Participante, échanges avec l'interlocuteur</a:t>
+                      </a:r>
+                    </a:p>
+                  </a:txBody>
+                  <a:tcPr marL="43200" marR="43200" marT="14400" marB="14400" anchor="ctr">
+                    <a:solidFill>
+                      <a:srgbClr val="F2F2F2"/>
+                    </a:solidFill>
+                  </a:tcPr>
+                </a:tc>
+              </a:tr>
             </a:tbl>
           </a:graphicData>
         </a:graphic>
@@ -13289,8 +13382,8 @@
         </p:nvSpPr>
         <p:spPr>
           <a:xfrm>
-            <a:off x="503999" y="3648303"/>
-            <a:ext cx="11232000" cy="2219696"/>
+            <a:off x="503999" y="3873553"/>
+            <a:ext cx="11232000" cy="1994446"/>
           </a:xfrm>
           <a:prstGeom prst="rect">
             <a:avLst/>
@@ -13380,7 +13473,7 @@
                 </a:solidFill>
                 <a:latin typeface="Helvetica"/>
               </a:rPr>
-              <a:t>Sigles : FPPN : Fonds de prévoyance de la Police nationale | EFC : entraide fin de carrière | PBC : liste des documents demandés au client</a:t>
+              <a:t>Sigles : FPPN : Fonds de prévoyance de la Police nationale | PBC : liste des documents demandés au client</a:t>
             </a:r>
           </a:p>
         </p:txBody>
@@ -14288,22 +14381,13 @@
               </a:spcAft>
             </a:pPr>
             <a:r>
-              <a:rPr sz="1200" b="1">
-                <a:solidFill>
-                  <a:srgbClr val="060606"/>
-                </a:solidFill>
-                <a:latin typeface="Helvetica"/>
-              </a:rPr>
-              <a:t>Implication pour la mission.</a:t>
-            </a:r>
-            <a:r>
               <a:rPr sz="1200" b="0">
                 <a:solidFill>
                   <a:srgbClr val="060606"/>
                 </a:solidFill>
                 <a:latin typeface="Helvetica"/>
               </a:rPr>
-              <a:t> Les écarts entre ce qui est demandé et ce qui est précompté ne sont pas expliqués par le FPPN : Adenka les mesure à partir des fichiers (rapport, partie 3), mais leur justification doit venir du FPPN.</a:t>
+              <a:t>Les écarts entre ce qui est demandé et ce qui est précompté ne sont pas expliqués par le FPPN : Adenka les mesure à partir des fichiers (rapport, partie 3), mais leur justification doit venir du FPPN.</a:t>
             </a:r>
           </a:p>
         </p:txBody>
@@ -14344,7 +14428,7 @@
     </p:spTree>
     <p:extLst>
       <p:ext uri="{BB962C8B-B14F-4D97-AF65-F5344CB8AC3E}">
-        <p14:creationId xmlns:p14="http://schemas.microsoft.com/office/powerpoint/2010/main" val="3827131149"/>
+        <p14:creationId xmlns:p14="http://schemas.microsoft.com/office/powerpoint/2010/main" val="3114359072"/>
       </p:ext>
     </p:extLst>
   </p:cSld>
@@ -16287,22 +16371,13 @@
               </a:spcAft>
             </a:pPr>
             <a:r>
-              <a:rPr sz="950" b="1">
-                <a:solidFill>
-                  <a:srgbClr val="060606"/>
-                </a:solidFill>
-                <a:latin typeface="Helvetica"/>
-              </a:rPr>
-              <a:t>Implication pour le FPPN.</a:t>
-            </a:r>
-            <a:r>
               <a:rPr sz="950" b="0">
                 <a:solidFill>
                   <a:srgbClr val="060606"/>
                 </a:solidFill>
                 <a:latin typeface="Helvetica"/>
               </a:rPr>
-              <a:t> Pour la maladie et le décès, le FPPN ne dispose pas de ce qui aurait dû être précompté : il ne peut pas mesurer ses pertes de cotisations. Pour les autres produits, il dispose des deux fichiers mais ne les rapproche pas.</a:t>
+              <a:t>Pour la maladie et le décès, le FPPN ne dispose pas de ce qui aurait dû être précompté : il ne peut pas mesurer ses pertes de cotisations. Pour les autres produits, il dispose des deux fichiers mais ne les rapproche pas.</a:t>
             </a:r>
           </a:p>
         </p:txBody>
@@ -16343,7 +16418,7 @@
     </p:spTree>
     <p:extLst>
       <p:ext uri="{BB962C8B-B14F-4D97-AF65-F5344CB8AC3E}">
-        <p14:creationId xmlns:p14="http://schemas.microsoft.com/office/powerpoint/2010/main" val="425468236"/>
+        <p14:creationId xmlns:p14="http://schemas.microsoft.com/office/powerpoint/2010/main" val="1859386097"/>
       </p:ext>
     </p:extLst>
   </p:cSld>
@@ -17353,22 +17428,13 @@
               </a:spcAft>
             </a:pPr>
             <a:r>
-              <a:rPr sz="1200" b="1">
-                <a:solidFill>
-                  <a:srgbClr val="060606"/>
-                </a:solidFill>
-                <a:latin typeface="Helvetica"/>
-              </a:rPr>
-              <a:t>Implication pour la mission.</a:t>
-            </a:r>
-            <a:r>
               <a:rPr sz="1200" b="0">
                 <a:solidFill>
                   <a:srgbClr val="060606"/>
                 </a:solidFill>
                 <a:latin typeface="Helvetica"/>
               </a:rPr>
-              <a:t> Les fichiers aller maladie et décès doivent être demandés à la direction du personnel de la Police ou à la Solde (PBC, item 61). Sans eux, le taux de recouvrement des cotisations exigé par la Décision n° 05/2022 (au moins 90 %) ne peut pas être calculé pour ces postes.</a:t>
+              <a:t>Les fichiers aller maladie et décès doivent être demandés à la direction du personnel de la Police ou à la Solde (PBC, item 61). Sans eux, le taux de recouvrement des cotisations exigé par la Décision n° 05/2022 (au moins 90 %) ne peut pas être calculé pour ces postes.</a:t>
             </a:r>
           </a:p>
         </p:txBody>
@@ -17409,7 +17475,7 @@
     </p:spTree>
     <p:extLst>
       <p:ext uri="{BB962C8B-B14F-4D97-AF65-F5344CB8AC3E}">
-        <p14:creationId xmlns:p14="http://schemas.microsoft.com/office/powerpoint/2010/main" val="587476997"/>
+        <p14:creationId xmlns:p14="http://schemas.microsoft.com/office/powerpoint/2010/main" val="1260394637"/>
       </p:ext>
     </p:extLst>
   </p:cSld>
@@ -18472,22 +18538,13 @@
               </a:spcAft>
             </a:pPr>
             <a:r>
-              <a:rPr sz="1100" b="1">
-                <a:solidFill>
-                  <a:srgbClr val="060606"/>
-                </a:solidFill>
-                <a:latin typeface="Helvetica"/>
-              </a:rPr>
-              <a:t>Implication pour la mission.</a:t>
-            </a:r>
-            <a:r>
               <a:rPr sz="1100" b="0">
                 <a:solidFill>
                   <a:srgbClr val="060606"/>
                 </a:solidFill>
                 <a:latin typeface="Helvetica"/>
               </a:rPr>
-              <a:t> Les engagements d'épargne se calculeront sur les montants réellement précomptés. Le règlement de chaque produit reste indispensable pour connaître les échéances et les conditions de retrait.</a:t>
+              <a:t>Les engagements d'épargne se calculeront sur les montants réellement précomptés. Le règlement de chaque produit reste indispensable pour connaître les échéances et les conditions de retrait.</a:t>
             </a:r>
           </a:p>
         </p:txBody>
@@ -18528,7 +18585,7 @@
     </p:spTree>
     <p:extLst>
       <p:ext uri="{BB962C8B-B14F-4D97-AF65-F5344CB8AC3E}">
-        <p14:creationId xmlns:p14="http://schemas.microsoft.com/office/powerpoint/2010/main" val="1196590057"/>
+        <p14:creationId xmlns:p14="http://schemas.microsoft.com/office/powerpoint/2010/main" val="1743650904"/>
       </p:ext>
     </p:extLst>
   </p:cSld>
@@ -19591,22 +19648,13 @@
               </a:spcAft>
             </a:pPr>
             <a:r>
-              <a:rPr sz="1100" b="1">
-                <a:solidFill>
-                  <a:srgbClr val="060606"/>
-                </a:solidFill>
-                <a:latin typeface="Helvetica"/>
-              </a:rPr>
-              <a:t>Implication pour le FPPN.</a:t>
-            </a:r>
-            <a:r>
               <a:rPr sz="1100" b="0">
                 <a:solidFill>
                   <a:srgbClr val="060606"/>
                 </a:solidFill>
                 <a:latin typeface="Helvetica"/>
               </a:rPr>
-              <a:t> Un rapprochement mensuel simple (aller, retour, motifs) permettrait de relancer les précomptes manqués et de justifier chaque écart.</a:t>
+              <a:t>Un rapprochement mensuel simple (aller, retour, motifs) permettrait de relancer les précomptes manqués et de justifier chaque écart.</a:t>
             </a:r>
           </a:p>
         </p:txBody>
@@ -19647,7 +19695,7 @@
     </p:spTree>
     <p:extLst>
       <p:ext uri="{BB962C8B-B14F-4D97-AF65-F5344CB8AC3E}">
-        <p14:creationId xmlns:p14="http://schemas.microsoft.com/office/powerpoint/2010/main" val="1819382340"/>
+        <p14:creationId xmlns:p14="http://schemas.microsoft.com/office/powerpoint/2010/main" val="2133672584"/>
       </p:ext>
     </p:extLst>
   </p:cSld>
@@ -21189,22 +21237,13 @@
               </a:spcAft>
             </a:pPr>
             <a:r>
-              <a:rPr sz="1100" b="1">
-                <a:solidFill>
-                  <a:srgbClr val="060606"/>
-                </a:solidFill>
-                <a:latin typeface="Helvetica"/>
-              </a:rPr>
-              <a:t>Implication pour le FPPN.</a:t>
-            </a:r>
-            <a:r>
               <a:rPr sz="1100" b="0">
                 <a:solidFill>
                   <a:srgbClr val="060606"/>
                 </a:solidFill>
                 <a:latin typeface="Helvetica"/>
               </a:rPr>
-              <a:t> Une table de correspondance matricule et mécano, fournie par la direction du personnel, éviterait le report manuel et sécuriserait le premier précompte.</a:t>
+              <a:t>Une table de correspondance matricule et mécano, fournie par la direction du personnel, éviterait le report manuel et sécuriserait le premier précompte.</a:t>
             </a:r>
           </a:p>
         </p:txBody>
@@ -21245,7 +21284,7 @@
     </p:spTree>
     <p:extLst>
       <p:ext uri="{BB962C8B-B14F-4D97-AF65-F5344CB8AC3E}">
-        <p14:creationId xmlns:p14="http://schemas.microsoft.com/office/powerpoint/2010/main" val="2665060541"/>
+        <p14:creationId xmlns:p14="http://schemas.microsoft.com/office/powerpoint/2010/main" val="782022283"/>
       </p:ext>
     </p:extLst>
   </p:cSld>
@@ -22002,22 +22041,13 @@
               </a:spcAft>
             </a:pPr>
             <a:r>
-              <a:rPr sz="1100" b="1">
-                <a:solidFill>
-                  <a:srgbClr val="060606"/>
-                </a:solidFill>
-                <a:latin typeface="Helvetica"/>
-              </a:rPr>
-              <a:t>Implication pour la mission.</a:t>
-            </a:r>
-            <a:r>
               <a:rPr sz="1100" b="0">
                 <a:solidFill>
                   <a:srgbClr val="060606"/>
                 </a:solidFill>
                 <a:latin typeface="Helvetica"/>
               </a:rPr>
-              <a:t> La politique de crédit lisible et la documentation de MEDOC et de la flotte sont nécessaires pour apprécier les engagements que ces produits font porter au FPPN.</a:t>
+              <a:t>La politique de crédit lisible et la documentation de MEDOC et de la flotte sont nécessaires pour apprécier les engagements que ces produits font porter au FPPN.</a:t>
             </a:r>
           </a:p>
         </p:txBody>
@@ -22058,7 +22088,7 @@
     </p:spTree>
     <p:extLst>
       <p:ext uri="{BB962C8B-B14F-4D97-AF65-F5344CB8AC3E}">
-        <p14:creationId xmlns:p14="http://schemas.microsoft.com/office/powerpoint/2010/main" val="2658079660"/>
+        <p14:creationId xmlns:p14="http://schemas.microsoft.com/office/powerpoint/2010/main" val="232626324"/>
       </p:ext>
     </p:extLst>
   </p:cSld>

</xml_diff>